<commit_message>
L06: republish at 32 slides, aligned with the labs and the Apply packet
</commit_message>
<xml_diff>
--- a/lectures/L06/slides.pptx
+++ b/lectures/L06/slides.pptx
@@ -533,9 +533,10 @@
           <a:p>
             <a:r>
               <a:rPr lang="en-US" dirty="0"/>
-              <a:t>This closes Apply and opens Analyze. The room is three days into the build and
-has working F1 to F3, so every argument today can be made against their own
-source rather than against somebody else's tool.
+              <a:t>This closes Apply and opens Analyze. The room was handed the build this week
+and, on track, is inside the design rather than running code, so every argument
+today is made against their own specification, by requirement ID, rather than
+against somebody else's tool.
 Nothing about Analyze is due next week. Say that more than once.</a:t>
             </a:r>
             <a:endParaRPr lang="en-US" dirty="0"/>
@@ -716,6 +717,9 @@
 point. /add is them choosing. read_file as a tool is the program choosing,
 which means it can go and look at something nobody mentioned because of
 something it saw two steps ago.
+L02's rule survives the move: the best context is the smallest that holds the
+relevant information. A model picking its own reads is filling its own
+haystack, which is one reason the stop conditions are code.
 Flag run_command and move on. It gets fifteen minutes after the break.</a:t>
             </a:r>
             <a:endParaRPr lang="en-US" dirty="0"/>
@@ -808,7 +812,11 @@
 model replies with a structured request rather than text.
 Walk the JSON slowly. This shape is the entire reason an approval layer is
 possible at all: there is a moment, after the ask and before the act, that
-belongs to code they wrote.</a:t>
+belongs to code they wrote. L04 showed them that moment already, as the
+architect pause: the cheapest place to catch a misunderstanding, because
+nothing has touched disk.
+Lab02's example does this with a JSON action their own parser recognizes rather
+than native function calling. Same shape; either is a valid protocol.</a:t>
             </a:r>
             <a:endParaRPr lang="en-US" dirty="0"/>
           </a:p>
@@ -896,7 +904,10 @@
           <a:p>
             <a:r>
               <a:rPr lang="en-US" dirty="0"/>
-              <a:t>The sentence to carry out of the first half.
+              <a:t>The sentence to carry out of the first half. L02 said it in week one: the core
+inference call has no lookup and no hands; tools are wrapped on by a program,
+and they were told they would write those tools in week 5. This is that
+promise being kept.
 If a student objects that Claude Code clearly ran commands on Tuesday: it
 asked, and the harness ran them, having consulted a permission setting. Same
 shape, more polish.</a:t>
@@ -1174,9 +1185,11 @@
               <a:t>A loop that runs until the model says it is finished will sometimes not finish.
 Same tool, same arguments, forever. Or it decides a task is complete when it is
 not.
-Their F6.10 already restores every affected file when an apply fails. That
-requirement gets considerably more interesting when the thing being interrupted
-is a loop rather than a turn.</a:t>
+They have the beginnings of the last one. F6.6 says an interrupt at the prompt
+writes nothing; F6.10 restores every affected file when a write fails part way.
+What Stage 1 scopes out, a crash mid-write, is what an unattended loop has to
+survive. That requirement gets considerably more interesting when the thing
+being interrupted is a loop rather than a turn.</a:t>
             </a:r>
             <a:endParaRPr lang="en-US" dirty="0"/>
           </a:p>
@@ -1446,8 +1459,9 @@
             <a:r>
               <a:rPr lang="en-US" dirty="0"/>
               <a:t>Structural fact and they should hear it from you before they read it in the
-spec: the first increment they committed this week is in the same history as
-the agent they gate in week 7.
+Analyze packet: the design they commit this week is in the same history as the
+agent they gate in week 7. Lab01 called this milestone M2; the packet calls it
+v0.
 It is also the cheapest authenticity evidence the course has, though you do not
 need to say that part.</a:t>
             </a:r>
@@ -1537,10 +1551,14 @@
           <a:p>
             <a:r>
               <a:rPr lang="en-US" dirty="0"/>
-              <a:t>Thirty seconds. Do not audit the room and do not ask who is behind; the office
-hours conversation is the place for that.
-The point of the slide is that they hold a real artifact. Everything today is
-argued against it.</a:t>
+              <a:t>Thirty seconds. Do not audit the room and do not ask who has code; the office
+hours conversation is the place for that. On track on Thursday means inside the
+design, and the rubric reads that order out of git history.
+L04's spec discipline grows into these files: the system design is what the
+increment specs cite, and each increment spec is the bounded, ordered kind they
+wrote for taskr.
+The point of the slide is that they hold a real specification. Everything today
+is argued against it, by requirement ID.</a:t>
             </a:r>
             <a:endParaRPr lang="en-US" dirty="0"/>
           </a:p>
@@ -1628,7 +1646,7 @@
           <a:p>
             <a:r>
               <a:rPr lang="en-US" dirty="0"/>
-              <a:t>Built in weeks 5 to 7. Week 4 belongs to Apply, and the spec itself does not
+              <a:t>Built in weeks 5 to 7. Week 4 belongs to Apply, and the Analyze packet does not
 land until October 6, when the build is due.
 Week 5 is the week the program stops being a pair-programmer. Week 6 is where
 the human actually leaves. Week 7 is where they find out what that cost.</a:t>
@@ -1989,7 +2007,7 @@
           <a:p>
             <a:r>
               <a:rPr lang="en-US" dirty="0"/>
-              <a:t>F7.3 and F7.5. They built this and it works.
+              <a:t>F7.3, F7.5 and F7.6. They are designing this, and the spec is exact about it.
 Emphasize "complete". There is no hole in it today, because git's model of the
 world is files and files are the only thing their program touches.</a:t>
             </a:r>
@@ -2081,8 +2099,8 @@
               <a:rPr lang="en-US" dirty="0"/>
               <a:t>Go slowly and let the list land. The net now has a hole in it the exact size of
 everything git does not track.
-And the loop issuing those commands is on their own laptop, driven by a 9B
-model they have watched be confidently wrong for two weeks.
+And the loop issuing those commands is on their own laptop, driven by a 4B
+or a 9B, models they have watched be confidently wrong for two weeks.
 An earlier version of this course scheduled the permission model for week 10.
 That is five weeks of unsupervised shell access with nothing in front of it,
 which is not a pedagogical risk, it is a broken machine.</a:t>
@@ -2173,7 +2191,7 @@
           <a:p>
             <a:r>
               <a:rPr lang="en-US" dirty="0"/>
-              <a:t>Three of the four they have already written, for files. Point back at the F6.5
+              <a:t>Three of the four are already in their specification, for files. Point back at the F6.5
 diff and the F6.6 yes.
 Step one is the one worth dwelling on. After the model asks and before your
 code acts, there is a moment that belongs to them. Everything else is what they
@@ -2359,10 +2377,12 @@
             <a:r>
               <a:rPr lang="en-US" dirty="0"/>
               <a:t>The gate runs v0 against a fixed task with nobody in the room, so an agent that
-asks about every command cannot pass.
+asks about every command stalls, and L01 told them gates are scored rather than
+passed: it earns whatever it finished before it stalled.
 So the gate does not really measure whether the agent works. It measures the
-allowlist. Hackathon 2 in week 7 is a room full of people finding out which way
-they got it wrong.
+allowlist. They can run it at home all week; hackathon 2 in week 7 is the
+observed attempt, a room full of people finding out which way they got it
+wrong.
 The teardown report asks the question only the log can answer: which rules did
 you loosen to pass, and what did that cost you?</a:t>
             </a:r>
@@ -2455,12 +2475,17 @@
               <a:t>Say the caption out loud. A student who leaves thinking Analyze work starts
 Monday will spend the most valuable supported build time of the phase on the
 wrong thing.
-The spec does not exist for them until October 6, the day the build is due.
-That is deliberate: they never hold two graded specs at once. Analyze arrives
-in the lectures first and on paper later.
-Lab02 is increments, tests, and reconciling what they built against the design
-document they wrote. Bring the runnable increment to the hackathon; the feature
-prompt is revealed in the room.</a:t>
+The Analyze packet does not exist for them until October 6, the day the build
+is due. That is deliberate: they never hold two graded specs at once. Analyze
+arrives in the lectures first and on paper later.
+Lab02 opens with forty minutes on a stockroom app: functions become actions the
+model requests, in the shape they saw an hour ago, one increment built with
+Aider from an increment spec. Then seventy minutes of supported build: finish
+the design, then increments and tests, reconciled against design/SYSTEM.md.
+Hackathon 1 is two hours on a supplied, working application: they design and
+build its AI capabilities from a prompt revealed in the room and submit inside
+the session. It does not depend on their build and nothing from it goes into
+their build.</a:t>
             </a:r>
             <a:endParaRPr lang="en-US" dirty="0"/>
           </a:p>
@@ -2551,7 +2576,11 @@
               <a:t>That is how L05 closed. Today it becomes theirs, and in three weeks it stops
 needing them.
 Tuesday made the argument with Aider and a demo. Today the same argument gets
-made with their source code, which is a much harder place to hide.</a:t>
+made with their specification, which is a much harder place to hide, because
+every requirement has a number.
+Place the title's word once. L01's fourth wave and Tuesday's fifth rung call
+many agents at once orchestration, and that is Create. Today it means the
+harness's job: deciding what the model may choose from, and enforcing it.</a:t>
             </a:r>
             <a:endParaRPr lang="en-US" dirty="0"/>
           </a:p>
@@ -2730,10 +2759,11 @@
           <a:p>
             <a:r>
               <a:rPr lang="en-US" dirty="0"/>
-              <a:t>The bridge to L07.
-For two weeks the endpoint has been one line of configuration and a
-client.chat(messages) call somebody else wrote. That seal comes off on Tuesday,
-and Analyze starts in this room.</a:t>
+              <a:t>The bridge to L07, whose title says "the client you were handed".
+For two weeks the endpoint was one line in Aider's configuration and a client
+somebody else wrote. This week they are writing their own against ENDPOINT.md:
+the request, the roles, the stream. Tuesday opens both, the one they were
+handed and the one they are writing, and Analyze starts in this room.</a:t>
             </a:r>
             <a:endParaRPr lang="en-US" dirty="0"/>
           </a:p>
@@ -3001,8 +3031,15 @@
 remember. Aider has a loop, tools, planning in architect mode, and session
 state.
 Fixed means the repertoire was decided when the program was written, not when
-it ran. Shallow means nothing in a turn is chosen because of something
-discovered two steps earlier, since there are no two steps earlier.
+it ran: edit, resend a miss up to three times (the number Lab01 gave them), run
+the configured tests, plan first in architect mode. On the third try it has the
+moves it had on the first. Shallow means nothing in a turn is chosen because of
+something discovered two steps earlier, since there are no two steps earlier;
+the offer to add a file (L03) routes through their yes, and the repo map
+(Lab01) is a fixed ranking rule. Human-framed: Aider writes and commits before
+asking, so for two weeks the turn ended at the commit and their /undo. L01 put
+Aider in the third wave, a tool that reads and keeps going; finish the sentence
+for them: inside a boundary they drew.
 None of the three is an insult. A pair-programmer that narrowed its own scope
 would be a worse pair-programmer.</a:t>
             </a:r>
@@ -3092,11 +3129,14 @@
           <a:p>
             <a:r>
               <a:rPr lang="en-US" dirty="0"/>
-              <a:t>This is the slide the lecture turns on. Put their code on the screen if you can
-get a volunteer's repository up; otherwise read the requirement numbers and let
-them find them.
-F1.4 is a fixed repertoire written down as a requirement: their program has
-exactly one thing it does with a turn.</a:t>
+              <a:t>This is the slide the lecture turns on. Put SPEC.md on the screen and read the
+lines; let them find the IDs in their own copy.
+Section 1's "what this program is not" is a fixed repertoire written down as a
+requirement: the list of things it will not do is longer than the list it will.
+F1.4 makes every request the same three things and F5.1 parses one complete
+reply; F1.5 trims rather than reads when the budget is hit. Shallower than
+Aider: no repo map, no offer to add a file. Their program is more human-framed
+than the tool they are building it with.</a:t>
             </a:r>
             <a:endParaRPr lang="en-US" dirty="0"/>
           </a:p>
@@ -3184,10 +3224,15 @@
           <a:p>
             <a:r>
               <a:rPr lang="en-US" dirty="0"/>
-              <a:t>Pause here. They do not think of it as an approval layer and it is exactly one.
-Their program is constitutionally incapable of changing a file they did not put
-in front of it and did not say yes to. Hold that thought for forty minutes; the
-second half is what happens to it when a shell arrives.</a:t>
+              <a:t>Pause here. They do not think of it as an approval layer and it is exactly one,
+and it is one Aider does not have: Aider writes and commits, and /undo is the
+recovery.
+F5.4, F6.2 and F6.7 make it a mechanism rather than a request: a block naming a
+file outside the selected set is rejected however confidently the model asked,
+and F4.4 says the prompt is not what enforces it. Their program is
+constitutionally incapable of changing a file they did not put in front of it
+and did not say yes to. Hold that thought for forty minutes; the second half is
+what happens to it when a shell arrives.</a:t>
             </a:r>
             <a:endParaRPr lang="en-US" dirty="0"/>
           </a:p>
@@ -3275,11 +3320,16 @@
           <a:p>
             <a:r>
               <a:rPr lang="en-US" dirty="0"/>
-              <a:t>Strip the vocabulary away and this is all a pair-programmer is.
-Take the first away and the program has to find its own context, which is a
-search problem. Take the third away and it has to know when it is done, which
-is a stop-condition problem. Both arrive later in the course.
-Number two is today.</a:t>
+              <a:t>Strip the vocabulary away and this is all a pair-programmer is. One is L03's
+context lever; two is its prompt lever, one bounded task per turn, which
+Tuesday called where the task ends; three is the commit and /undo for Aider,
+and the yes or no at the prompt for their build.
+Lab01's harness table had four rows: what the model sees, what happens to a
+reply, what comes next, what survives the session. These are the first three
+from the person's side; the fourth is on v0's exclusion list.
+Number two is today. Taking it away forces the other two: a program choosing
+its next step has to choose what to read (a search problem) and when it is
+finished (a stop-condition problem).</a:t>
             </a:r>
             <a:endParaRPr lang="en-US" dirty="0"/>
           </a:p>
@@ -3368,10 +3418,15 @@
             <a:r>
               <a:rPr lang="en-US" dirty="0"/>
               <a:t>Say it and leave it up for a beat.
-Not new intelligence, not a better model. The same model, handed a set of
-actions and a loop that lets it pick the next one, behaves like a different
-category of software. Everything people find strange about agentic tools
-follows from that single move.</a:t>
+They still type the goal. What they stop supplying is the next step. Not new
+intelligence, not a better model (L03: the failure was never the model, and the
+fix is not the model either). The same model, handed a set of actions and a
+loop that lets it pick the next one, behaves like a different category of
+software.
+If someone says L04's architect run already did this: they pasted a whole spec
+and read the result, but the spec listed its steps in order so the model would
+not have to discover them. Decision two, supplied in advance. An agent
+discovers the order as it goes.</a:t>
             </a:r>
             <a:endParaRPr lang="en-US" dirty="0"/>
           </a:p>

</xml_diff>

<commit_message>
L06: republish, slide 2 packet bullet
</commit_message>
<xml_diff>
--- a/lectures/L06/slides.pptx
+++ b/lectures/L06/slides.pptx
@@ -1554,9 +1554,11 @@
               <a:t>Thirty seconds. Do not audit the room and do not ask who has code; the office
 hours conversation is the place for that. On track on Thursday means inside the
 design, and the rubric reads that order out of git history.
-L04's spec discipline grows into these files: the system design is what the
-increment specs cite, and each increment spec is the bounded, ordered kind they
-wrote for taskr.
+README's reading order is EXAMPLES.md, then SPEC.md and RUBRIC.md; SPEC.md is
+the staff contract, seven features with requirement IDs. The other two bullets
+are what they write: L04's spec discipline grows into them, the system design
+is what the increment specs cite, and each increment spec (specs/, one per
+Aider increment) is the bounded, ordered kind they wrote for taskr.
 The point of the slide is that they hold a real specification. Everything today
 is argued against it, by requirement ID.</a:t>
             </a:r>

</xml_diff>

<commit_message>
L06: republish, slide 3 wording
</commit_message>
<xml_diff>
--- a/lectures/L06/slides.pptx
+++ b/lectures/L06/slides.pptx
@@ -2575,8 +2575,9 @@
           <a:p>
             <a:r>
               <a:rPr lang="en-US" dirty="0"/>
-              <a:t>That is how L05 closed. Today it becomes theirs, and in three weeks it stops
-needing them.
+              <a:t>L05's last slide said "Thursday, the loop stops being someone else's". It is
+Thursday. Today the loop is theirs as a specification, it becomes theirs as
+code across the build, and in three weeks it stops needing them.
 Tuesday made the argument with Aider and a demo. Today the same argument gets
 made with their specification, which is a much harder place to hide, because
 every requirement has a number.

</xml_diff>

<commit_message>
L06: republish, three tool calls on slide 12
</commit_message>
<xml_diff>
--- a/lectures/L06/slides.pptx
+++ b/lectures/L06/slides.pptx
@@ -809,7 +809,9 @@
             <a:r>
               <a:rPr lang="en-US" dirty="0"/>
               <a:t>You describe each tool as a name, a description, and a parameter schema. The
-model replies with a structured request rather than text.
+model replies with a structured request rather than text. The three calls are
+the three verbs from the last slide; a reply may carry one or several, which is
+why the loop slide iterates over the array.
 Walk the JSON slowly. This shape is the entire reason an approval layer is
 possible at all: there is a moment, after the ask and before the act, that
 belongs to code they wrote. L04 showed them that moment already, as the

</xml_diff>

<commit_message>
L06: republish, slide 15 table
</commit_message>
<xml_diff>
--- a/lectures/L06/slides.pptx
+++ b/lectures/L06/slides.pptx
@@ -1093,7 +1093,9 @@
             <a:r>
               <a:rPr lang="en-US" dirty="0"/>
               <a:t>Worth being explicit, because the loop slide reads as a loss of control and it
-is not, quite.
+is not, quite. Read the table by row: the model's output is still text in both
+columns; every read, write and command is still executed by code they wrote;
+the only cell that changes is who picks the next action.
 Tie it back to Tuesday's question, which is now answered from the inside: who
 picks the next action. In week 5 their own code will be the thing that stopped
 picking.</a:t>

</xml_diff>

<commit_message>
L06: republish, chat break on taskr and packet timing
</commit_message>
<xml_diff>
--- a/lectures/L06/slides.pptx
+++ b/lectures/L06/slides.pptx
@@ -533,10 +533,10 @@
           <a:p>
             <a:r>
               <a:rPr lang="en-US" dirty="0"/>
-              <a:t>This closes Apply and opens Analyze. The room was handed the build this week
-and, on track, is inside the design rather than running code, so every argument
-today is made against their own specification, by requirement ID, rather than
-against somebody else's tool.
+              <a:t>This closes Apply and opens Analyze. Lab01 introduced the build and the packet
+goes out right after this lecture, so nobody has code or the spec in hand yet.
+Every argument today is made against the specification on the screen, by
+requirement ID, rather than against somebody else's tool.
 Nothing about Analyze is due next week. Say that more than once.</a:t>
             </a:r>
             <a:endParaRPr lang="en-US" dirty="0"/>
@@ -1463,7 +1463,7 @@
             <a:r>
               <a:rPr lang="en-US" dirty="0"/>
               <a:t>Structural fact and they should hear it from you before they read it in the
-Analyze packet: the design they commit this week is in the same history as the
+Analyze packet: the first design they commit is in the same history as the
 agent they gate in week 7. Lab01 called this milestone M2; the packet calls it
 v0.
 It is also the cheapest authenticity evidence the course has, though you do not
@@ -1555,16 +1555,17 @@
           <a:p>
             <a:r>
               <a:rPr lang="en-US" dirty="0"/>
-              <a:t>Thirty seconds. Do not audit the room and do not ask who has code; the office
-hours conversation is the place for that. On track on Thursday means inside the
-design, and the rubric reads that order out of git history.
+              <a:t>Thirty seconds. The packet goes out right after this lecture, so nobody has it
+yet and nobody has code. The first thing it asks for is the design, and the
+rubric reads that order out of git history.
 README's reading order is EXAMPLES.md, then SPEC.md and RUBRIC.md; SPEC.md is
 the staff contract, seven features with requirement IDs. The other two bullets
 are what they write: L04's spec discipline grows into them, the system design
 is what the increment specs cite, and each increment spec (specs/, one per
 Aider increment) is the bounded, ordered kind they wrote for taskr.
-The point of the slide is that they hold a real specification. Everything today
-is argued against it, by requirement ID.</a:t>
+The point of the slide is that a real specification is about to be theirs.
+Everything today is argued against it, by requirement ID, with SPEC.md on the
+screen.</a:t>
             </a:r>
             <a:endParaRPr lang="en-US" dirty="0"/>
           </a:p>
@@ -2486,8 +2487,8 @@
 arrives in the lectures first and on paper later.
 Lab02 opens with forty minutes on a stockroom app: functions become actions the
 model requests, in the shape they saw an hour ago, one increment built with
-Aider from an increment spec. Then seventy minutes of supported build: finish
-the design, then increments and tests, reconciled against design/SYSTEM.md.
+Aider from an increment spec. Then seventy minutes of supported build: the
+design first, then increments and tests, reconciled against design/SYSTEM.md.
 Hackathon 1 is two hours on a supplied, working application: they design and
 build its AI capabilities from a prompt revealed in the room and submit inside
 the session. It does not depend on their build and nothing from it goes into
@@ -3137,7 +3138,7 @@
             <a:r>
               <a:rPr lang="en-US" dirty="0"/>
               <a:t>This is the slide the lecture turns on. Put SPEC.md on the screen and read the
-lines; let them find the IDs in their own copy.
+lines; they get their own copy tonight.
 Section 1's "what this program is not" is a fixed repertoire written down as a
 requirement: the list of things it will not do is longer than the list it will.
 F1.4 makes every request the same three things and F5.1 parses one complete

</xml_diff>

<commit_message>
L06: republish, slide 15 column headers
</commit_message>
<xml_diff>
--- a/lectures/L06/slides.pptx
+++ b/lectures/L06/slides.pptx
@@ -1093,8 +1093,9 @@
             <a:r>
               <a:rPr lang="en-US" dirty="0"/>
               <a:t>Worth being explicit, because the loop slide reads as a loss of control and it
-is not, quite. Read the table by row: the model's output is still text in both
-columns; every read, write and command is still executed by code they wrote;
+is not, quite. The columns are Lab01's milestones; v0 is not named until the
+Agent v0 section. Read the table by row: the model's output is still text in
+both columns; every read, write and command is still executed by code they wrote;
 the only cell that changes is who picks the next action.
 Tie it back to Tuesday's question, which is now answered from the inside: who
 picks the next action. In week 5 their own code will be the thing that stopped

</xml_diff>

<commit_message>
L06: republish at 39 slides, Rafe's rework with the slide 16 caption fix
</commit_message>
<xml_diff>
--- a/lectures/L06/slides.pptx
+++ b/lectures/L06/slides.pptx
@@ -37,9 +37,16 @@
     <p:sldId id="285" r:id="rId31"/>
     <p:sldId id="286" r:id="rId32"/>
     <p:sldId id="287" r:id="rId33"/>
+    <p:sldId id="288" r:id="rId34"/>
+    <p:sldId id="289" r:id="rId35"/>
+    <p:sldId id="290" r:id="rId36"/>
+    <p:sldId id="291" r:id="rId37"/>
+    <p:sldId id="292" r:id="rId38"/>
+    <p:sldId id="293" r:id="rId39"/>
+    <p:sldId id="294" r:id="rId40"/>
   </p:sldIdLst>
   <p:notesMasterIdLst>
-    <p:notesMasterId r:id="rId34"/>
+    <p:notesMasterId r:id="rId41"/>
   </p:notesMasterIdLst>
   <p:sldSz cx="9334500" cy="5248275"/>
   <p:notesSz cx="5248275" cy="9334500"/>
@@ -533,11 +540,9 @@
           <a:p>
             <a:r>
               <a:rPr lang="en-US" dirty="0"/>
-              <a:t>This closes Apply and opens Analyze. Lab01 introduced the build and the packet
-goes out right after this lecture, so nobody has code or the spec in hand yet.
-Every argument today is made against the specification on the screen, by
-requirement ID, rather than against somebody else's tool.
-Nothing about Analyze is due next week. Say that more than once.</a:t>
+              <a:t>Three parts today. The project packet that lands after this lecture, how to
+work with a model whose code you have to understand, and how the one command
+their program already has grows into tool calling and an agent loop.</a:t>
             </a:r>
             <a:endParaRPr lang="en-US" dirty="0"/>
           </a:p>
@@ -625,7 +630,14 @@
           <a:p>
             <a:r>
               <a:rPr lang="en-US" dirty="0"/>
-              <a:t/>
+              <a:t>This is the shift the course is built on. Writing code by hand has dropped off,
+and so has reading every line. Nobody can keep up with a model line by line, and
+that is not the goal. The goal is knowing what the code decides and whether it
+does what you meant. "The model wrote it" is still not an answer to any rubric
+row.
+So the engineering work moves. It moves into the plan, the prompt, and above all
+into understanding what came back: the code, and also the prose around the code,
+where the model says what it did.</a:t>
             </a:r>
             <a:endParaRPr lang="en-US" dirty="0"/>
           </a:p>
@@ -713,14 +725,12 @@
           <a:p>
             <a:r>
               <a:rPr lang="en-US" dirty="0"/>
-              <a:t>Read file sounds redundant when /add exists, and the difference is the whole
-point. /add is them choosing. read_file as a tool is the program choosing,
-which means it can go and look at something nobody mentioned because of
-something it saw two steps ago.
-L02's rule survives the move: the best context is the smallest that holds the
-relevant information. A model picking its own reads is filling its own
-haystack, which is one reason the stop conditions are code.
-Flag run_command and move on. It gets fifteen minutes after the break.</a:t>
+              <a:t>Every session the model starts from the files you gave it. You are the one who
+remembers that the trimming policy was decided last Tuesday, that increment 3
+is half done, and that "all tests pass" came from the model, not from bin/test.
+The last two bullets are the dangerous pair. Verified and claimed look identical
+in a chat window. Keeping them apart is your job, and it is done in your head
+unless you give it somewhere better to live.</a:t>
             </a:r>
             <a:endParaRPr lang="en-US" dirty="0"/>
           </a:p>
@@ -808,17 +818,14 @@
           <a:p>
             <a:r>
               <a:rPr lang="en-US" dirty="0"/>
-              <a:t>You describe each tool as a name, a description, and a parameter schema. The
-model replies with a structured request rather than text. The three calls are
-the three verbs from the last slide; a reply may carry one or several, which is
-why the loop slide iterates over the array.
-Walk the JSON slowly. This shape is the entire reason an approval layer is
-possible at all: there is a moment, after the ask and before the act, that
-belongs to code they wrote. L04 showed them that moment already, as the
-architect pause: the cheapest place to catch a misunderstanding, because
-nothing has touched disk.
-Lab02's example does this with a JSON action their own parser recognizes rather
-than native function calling. Same shape; either is a valid protocol.</a:t>
+              <a:t>This is genuinely hard and nobody gets it right the first week.
+Too close and you are reading at human speed behind a model that writes at
+machine speed, and you still miss the decision that mattered. Too far and you are
+rubber-stamping, which is how a stale-preview bug ends up in a build that
+"works".
+About right means you know which decisions matter, you check that each one was
+kept, and you let tests and diffs carry the detail. You cannot do that without
+a way to point at the decisions. Which is the next slide.</a:t>
             </a:r>
             <a:endParaRPr lang="en-US" dirty="0"/>
           </a:p>
@@ -906,13 +913,8 @@
           <a:p>
             <a:r>
               <a:rPr lang="en-US" dirty="0"/>
-              <a:t>The sentence to carry out of the first half. L02 said it in week one: the core
-inference call has no lookup and no hands; tools are wrapped on by a program,
-and they were told they would write those tools in week 5. This is that
-promise being kept.
-If a student objects that Claude Code clearly ran commands on Tuesday: it
-asked, and the harness ran them, having consulted a permission setting. Same
-shape, more polish.</a:t>
+              <a:t>Pause. The rest of this section is one construct, reference points, and then
+the question of what else does the same job.</a:t>
             </a:r>
             <a:endParaRPr lang="en-US" dirty="0"/>
           </a:p>
@@ -1000,11 +1002,15 @@
           <a:p>
             <a:r>
               <a:rPr lang="en-US" dirty="0"/>
-              <a:t>Six lines and the pair-programmer's loop is gone. Nothing in there says which
-file to read, what the next step is, or when to stop.
-The model supplies all three, turn after turn, from inside a single request the
-user typed once.
-This is week 5's lab. They will write this exact shape.</a:t>
+              <a:t>A reference point is a keyword for project state. It is dense: "F6" carries a
+whole feature in two characters, to a person across the table or into a prompt,
+and a harness can resolve it without the paragraph being pasted in.
+When you wrote the code yourself, the name of a thing lived in the code and you
+could go look. When a model writes the code from your plan and your prompt, the
+name has to live somewhere the model, the grader and you can all point at.
+Otherwise every one of them is interpreting a sentence.
+Under a context budget that compression is not tidiness. It is what makes the
+conversation fit.</a:t>
             </a:r>
             <a:endParaRPr lang="en-US" dirty="0"/>
           </a:p>
@@ -1092,14 +1098,12 @@
           <a:p>
             <a:r>
               <a:rPr lang="en-US" dirty="0"/>
-              <a:t>Worth being explicit, because the loop slide reads as a loss of control and it
-is not, quite. The columns are Lab01's milestones; v0 is not named until the
-Agent v0 section. Read the table by row: the model's output is still text in
-both columns; every read, write and command is still executed by code they wrote;
-the only cell that changes is who picks the next action.
-Tie it back to Tuesday's question, which is now answered from the inside: who
-picks the next action. In week 5 their own code will be the thing that stopped
-picking.</a:t>
+              <a:t>This is modeled on planning this lecture with Claude Code. The session was set up so
+that any time the model presented three or more decisions, options or findings,
+every one got a short code: D for decisions, O for options, Q for questions. The
+real table ran to D18.
+Point out that nothing about the model changed. One line in a conventions file
+told it to number things. The payoff is on the next slide.</a:t>
             </a:r>
             <a:endParaRPr lang="en-US" dirty="0"/>
           </a:p>
@@ -1187,14 +1191,13 @@
           <a:p>
             <a:r>
               <a:rPr lang="en-US" dirty="0"/>
-              <a:t>A loop that runs until the model says it is finished will sometimes not finish.
-Same tool, same arguments, forever. Or it decides a task is complete when it is
-not.
-They have the beginnings of the last one. F6.6 says an interrupt at the prompt
-writes nothing; F6.10 restores every affected file when a write fails part way.
-What Stage 1 scopes out, a crash mid-write, is what an unattended loop has to
-survive. That requirement gets considerably more interesting when the thing
-being interrupted is a loop rather than a turn.</a:t>
+              <a:t>Without codes, that first reply is a paragraph: "I agree with the demo idea and
+the markers, but I'd rather do the read part live..." and the model has to guess
+which proposal each clause is about. With codes, every clause lands on exactly
+one decision, and the model's answer is checkable the same way. It even caught
+that D2 was never answered.
+This is the working relationship at small scale. The model presents in names,
+you answer in names, and nothing gets lost between the two.</a:t>
             </a:r>
             <a:endParaRPr lang="en-US" dirty="0"/>
           </a:p>
@@ -1282,12 +1285,15 @@
           <a:p>
             <a:r>
               <a:rPr lang="en-US" dirty="0"/>
-              <a:t>**"OK, Zoom, we're on break."**
-Circulate. Five minutes.
-**"OK, Zoom, we're back."**
-Take two or three. Listen for whether anybody reaches for a rule rather than a
-yes or no. If somebody does, that is the second half and you can name them for
-it. If nobody does, say so out loud and use it as the transition.</a:t>
+              <a:t>This is why the packet is less specific. SPEC.md stops at the feature. The token
+estimator, the trimming policy, the delimiter, how an owned commit is marked,
+what each error says: those are decisions, and DESIGN-GUIDE section 1 asks for
+each one as an acceptance criterion with a stable ID of their own, mapped to the
+feature it serves. The rubric calls that mapping traceable and pays 10 points
+for it.
+The format is theirs. Something like F6-3 for "a stale preview is refused"
+works. What matters is that it is short, it never changes meaning, and it shows
+up in the design, the increment spec, the test name and the commit.</a:t>
             </a:r>
             <a:endParaRPr lang="en-US" dirty="0"/>
           </a:p>
@@ -1375,7 +1381,14 @@
           <a:p>
             <a:r>
               <a:rPr lang="en-US" dirty="0"/>
-              <a:t/>
+              <a:t>The left hands the model a sentence to interpret. It will interpret it, and it
+will pick its own idea of "safer".
+The right hands it an increment, a task boundary, one criterion, a test that
+decides whether it is done, and the file it may touch. Every one of those is a
+name the model can resolve against files in its context, and every one is
+something the student can check afterwards.
+A prompt that paraphrases a requirement drifts from it, and the model cannot
+tell. The ID does not drift.</a:t>
             </a:r>
             <a:endParaRPr lang="en-US" dirty="0"/>
           </a:p>
@@ -1463,12 +1476,12 @@
           <a:p>
             <a:r>
               <a:rPr lang="en-US" dirty="0"/>
-              <a:t>Structural fact and they should hear it from you before they read it in the
-Analyze packet: the first design they commit is in the same history as the
-agent they gate in week 7. Lab01 called this milestone M2; the packet calls it
-v0.
-It is also the cheapest authenticity evidence the course has, though you do not
-need to say that part.</a:t>
+              <a:t>Names work in both directions. Most of the work of understanding model output is
+separating what it did from what it says it did. Ask for the report in your
+terms and that separation is a checklist instead of a reading exercise.
+"Ran: nothing" is the line you were looking for. Without asking, that would have
+been a paragraph saying the change handles stale previews correctly.
+Then check it. The names make the claims checkable. They do not make them true.</a:t>
             </a:r>
             <a:endParaRPr lang="en-US" dirty="0"/>
           </a:p>
@@ -1556,17 +1569,8 @@
           <a:p>
             <a:r>
               <a:rPr lang="en-US" dirty="0"/>
-              <a:t>Thirty seconds. The packet goes out right after this lecture, so nobody has it
-yet and nobody has code. The first thing it asks for is the design, and the
-rubric reads that order out of git history.
-README's reading order is EXAMPLES.md, then SPEC.md and RUBRIC.md; SPEC.md is
-the staff contract, seven features with requirement IDs. The other two bullets
-are what they write: L04's spec discipline grows into them, the system design
-is what the increment specs cite, and each increment spec (specs/, one per
-Aider increment) is the bounded, ordered kind they wrote for taskr.
-The point of the slide is that a real specification is about to be theirs.
-Everything today is argued against it, by requirement ID, with SPEC.md on the
-screen.</a:t>
+              <a:t>Name the three and move on. The first is logistics and should be quick. The
+second is the one to spend time on. The third ends where Analyze begins.</a:t>
             </a:r>
             <a:endParaRPr lang="en-US" dirty="0"/>
           </a:p>
@@ -1654,10 +1658,12 @@
           <a:p>
             <a:r>
               <a:rPr lang="en-US" dirty="0"/>
-              <a:t>Built in weeks 5 to 7. Week 4 belongs to Apply, and the Analyze packet does not
-land until October 6, when the build is due.
-Week 5 is the week the program stops being a pair-programmer. Week 6 is where
-the human actually leaves. Week 7 is where they find out what that cost.</a:t>
+              <a:t>That line is a complete statement of where a project is, and none of it is a
+paraphrase. Staff at office hours know what to open. A fresh Aider or Claude
+Code session knows what to load. The commit history reads as a record of
+decisions.
+This is also the answer to "what you hold in your head". Written down in these
+terms, it stops living only in your head.</a:t>
             </a:r>
             <a:endParaRPr lang="en-US" dirty="0"/>
           </a:p>
@@ -1745,10 +1751,13 @@
           <a:p>
             <a:r>
               <a:rPr lang="en-US" dirty="0"/>
-              <a:t>State this plainly. Some of them have read about the tools in the June version
-of this course and will expect those things here.
-Every item is a week in Create, weeks 10 to 13, and they will be adding it to
-an agent they wrote rather than to a tool somebody handed them.</a:t>
+              <a:t>Paraphrase: the prompt says "the trimming rule" and the model picks one.
+Invented IDs: models are happy to cite F6-7 when there is no F6-7. Only use names
+that resolve to a line in a file.
+Not in context: a name is only as good as what it resolves to. If SYSTEM.md is
+not loaded, "section 6" is a guess. Check what the session can see.
+Changed meaning: renumbering criteria halfway through breaks every test name and
+commit that cited them. Add new IDs, do not reuse old ones.</a:t>
             </a:r>
             <a:endParaRPr lang="en-US" dirty="0"/>
           </a:p>
@@ -1836,10 +1845,10 @@
           <a:p>
             <a:r>
               <a:rPr lang="en-US" dirty="0"/>
-              <a:t>Leaving week 7 with a measured list of everything your agent cannot do is not a
-failure report.
-It is the only honest way to start the second half of a course like this, and
-it is why Analyze ends in a teardown report rather than a demo.</a:t>
+              <a:t>Switch to the terminal and drive it.
+Demo content to be written.
+Narrate the checking, not the typing. Every time the model makes a claim, say
+out loud whether it was verified or only stated.</a:t>
             </a:r>
             <a:endParaRPr lang="en-US" dirty="0"/>
           </a:p>
@@ -1927,7 +1936,20 @@
           <a:p>
             <a:r>
               <a:rPr lang="en-US" dirty="0"/>
-              <a:t/>
+              <a:t>**"OK, Zoom, we're on break."**
+Circulate. Five minutes.
+**"OK, Zoom, we're back."**
+Take five and write them on the board. Seeds if the room is quiet:
+- Ask for a plan before any edit
+- A fixed shape for every reply
+- A list of what was not verified
+- Small diffs, one task at a time
+- Tests as the judge, not the model's summary
+- A conventions file the model always loads
+- Diagrams the model has to keep current
+- Commit messages that cite IDs
+Close by pointing out that every one of these is a construct the engineer
+defines, not a feature of the model.</a:t>
             </a:r>
             <a:endParaRPr lang="en-US" dirty="0"/>
           </a:p>
@@ -2015,9 +2037,7 @@
           <a:p>
             <a:r>
               <a:rPr lang="en-US" dirty="0"/>
-              <a:t>F7.3, F7.5 and F7.6. They are designing this, and the spec is exact about it.
-Emphasize "complete". There is no hole in it today, because git's model of the
-world is files and files are the only thing their program touches.</a:t>
+              <a:t/>
             </a:r>
             <a:endParaRPr lang="en-US" dirty="0"/>
           </a:p>
@@ -2105,13 +2125,11 @@
           <a:p>
             <a:r>
               <a:rPr lang="en-US" dirty="0"/>
-              <a:t>Go slowly and let the list land. The net now has a hole in it the exact size of
-everything git does not track.
-And the loop issuing those commands is on their own laptop, driven by a 4B
-or a 9B, models they have watched be confidently wrong for two weeks.
-An earlier version of this course scheduled the permission model for week 10.
-That is five weeks of unsupervised shell access with nothing in front of it,
-which is not a pedagogical risk, it is a broken machine.</a:t>
+              <a:t>Look at this the other way round. The model writes text. The program finds a
+marker it recognizes, pulls out the arguments, and does something in the world
+with them, after asking.
+That is a command. Their program has exactly one. The question for the rest of
+the lecture is what happens when we add a second.</a:t>
             </a:r>
             <a:endParaRPr lang="en-US" dirty="0"/>
           </a:p>
@@ -2199,11 +2217,13 @@
           <a:p>
             <a:r>
               <a:rPr lang="en-US" dirty="0"/>
-              <a:t>Three of the four are already in their specification, for files. Point back at the F6.5
-diff and the F6.6 yes.
-Step one is the one worth dwelling on. After the model asks and before your
-code acts, there is a moment that belongs to them. Everything else is what they
-choose to do with it.</a:t>
+              <a:t>This happens constantly with Aider and it will happen with their program. The
+model sees one file, reasons about it, and says what it needs next. Aider cannot
+read a file on its own. It can offer to add one, but you still have to say yes
+and resend. Their Stage 1 program is stricter still: only /add puts a file in
+front of the model.
+So in this exchange the person did no thinking. The model named the file. The
+person typed it back.</a:t>
             </a:r>
             <a:endParaRPr lang="en-US" dirty="0"/>
           </a:p>
@@ -2291,12 +2311,12 @@
           <a:p>
             <a:r>
               <a:rPr lang="en-US" dirty="0"/>
-              <a:t>The prompt ships in week 5 with run_command because nothing else is protecting
-the machine, and because it is genuinely ten lines.
-The rules file waits a week on purpose. This is the design's own advice turned
-into a schedule: build the manual path, live with it, then write rules. They
-will want to skip to the rules. Tell them the week-6 lab depends on having a
-week of their own traffic to write against.</a:t>
+              <a:t>Take the objection seriously first. We made the user choose files on purpose:
+it keeps context small and keeps the user in control. Those are real reasons.
+But reading is the safest action there is. Nothing on disk changes, and there is
+nothing to undo. If the model can already name the file, making a person copy
+that name into /add adds a step and no judgment.
+So we let it ask. The same way it already asks for an edit.</a:t>
             </a:r>
             <a:endParaRPr lang="en-US" dirty="0"/>
           </a:p>
@@ -2384,15 +2404,12 @@
           <a:p>
             <a:r>
               <a:rPr lang="en-US" dirty="0"/>
-              <a:t>The gate runs v0 against a fixed task with nobody in the room, so an agent that
-asks about every command stalls, and L01 told them gates are scored rather than
-passed: it earns whatever it finished before it stalled.
-So the gate does not really measure whether the agent works. It measures the
-allowlist. They can run it at home all week; hackathon 2 in week 7 is the
-observed attempt, a room full of people finding out which way they got it
-wrong.
-The teardown report asks the question only the log can answer: which rules did
-you loosen to pass, and what did that cost you?</a:t>
+              <a:t>Same idea, different marker. The model asks for a file. The harness reads it and
+puts the contents in the next message.
+Compare with /add. /add is the user choosing. READ is the model choosing, because
+of something it saw a moment ago.
+This is not in the Stage 1 spec, and the markers here are made up for the
+lecture. The point is how little it takes.</a:t>
             </a:r>
             <a:endParaRPr lang="en-US" dirty="0"/>
           </a:p>
@@ -2480,20 +2497,10 @@
           <a:p>
             <a:r>
               <a:rPr lang="en-US" dirty="0"/>
-              <a:t>Say the caption out loud. A student who leaves thinking Analyze work starts
-Monday will spend the most valuable supported build time of the phase on the
-wrong thing.
-The Analyze packet does not exist for them until October 6, the day the build
-is due. That is deliberate: they never hold two graded specs at once. Analyze
-arrives in the lectures first and on paper later.
-Lab02 opens with forty minutes on a stockroom app: functions become actions the
-model requests, in the shape they saw an hour ago, one increment built with
-Aider from an increment spec. Then seventy minutes of supported build: the
-design first, then increments and tests, reconciled against design/SYSTEM.md.
-Hackathon 1 is two hours on a supplied, working application: they design and
-build its AI capabilities from a prompt revealed in the room and submit inside
-the session. It does not depend on their build and nothing from it goes into
-their build.</a:t>
+              <a:t>And again. The model asks for a command. The harness runs it and returns what it
+printed.
+Flag it: this is the first command that changes the machine rather than a file,
+and git does not undo it. Come back to that at the end.</a:t>
             </a:r>
             <a:endParaRPr lang="en-US" dirty="0"/>
           </a:p>
@@ -2581,15 +2588,7 @@
           <a:p>
             <a:r>
               <a:rPr lang="en-US" dirty="0"/>
-              <a:t>L05's last slide said "Thursday, the loop stops being someone else's". It is
-Thursday. Today the loop is theirs as a specification, it becomes theirs as
-code across the build, and in three weeks it stops needing them.
-Tuesday made the argument with Aider and a demo. Today the same argument gets
-made with their specification, which is a much harder place to hide, because
-every requirement has a number.
-Place the title's word once. L01's fourth wave and Tuesday's fifth rung call
-many agents at once orchestration, and that is Create. Today it means the
-harness's job: deciding what the model may choose from, and enforcing it.</a:t>
+              <a:t/>
             </a:r>
             <a:endParaRPr lang="en-US" dirty="0"/>
           </a:p>
@@ -2677,10 +2676,10 @@
           <a:p>
             <a:r>
               <a:rPr lang="en-US" dirty="0"/>
-              <a:t>Leave this up through questions.
-Number two comes back in week 6 as an actual file they write. Number three is
-the one that makes them better engineers this week, because it is a question
-about their own build's logging and they can act on it in Lab02.</a:t>
+              <a:t>Walk it line by line. One parser, one branch per command, and every branch ends
+the same way: a result goes back into the conversation.
+Ask the room what the fourth command would be. Search, list a directory, fetch a
+URL. Each one is another elif. Let them notice that the branches all look alike.</a:t>
             </a:r>
             <a:endParaRPr lang="en-US" dirty="0"/>
           </a:p>
@@ -2768,11 +2767,12 @@
           <a:p>
             <a:r>
               <a:rPr lang="en-US" dirty="0"/>
-              <a:t>The bridge to L07, whose title says "the client you were handed".
-For two weeks the endpoint was one line in Aider's configuration and a client
-somebody else wrote. This week they are writing their own against ENDPOINT.md:
-the request, the roles, the stream. Tuesday opens both, the one they were
-handed and the one they are writing, and Analyze starts in this room.</a:t>
+              <a:t>This is the step to slow down on. Strip the markers away and every command is
+the same two things: which one, and with what.
+Once you see that, the custom markers are just a clumsy encoding. Describe each
+command to the model as a name, a description and a parameter schema, and let
+it reply in a structured format instead. That is function calling. We did not
+add a new idea. We generalized the one their program already has.</a:t>
             </a:r>
             <a:endParaRPr lang="en-US" dirty="0"/>
           </a:p>
@@ -2860,7 +2860,11 @@
           <a:p>
             <a:r>
               <a:rPr lang="en-US" dirty="0"/>
-              <a:t/>
+              <a:t>The same table, in JSON. The endpoint does the formatting work, and the harness
+gets a list it can loop over instead of text it has to scan for markers.
+Nothing else changed. The dispatcher is the same if/elif, keyed on name. And
+once commands are just names in a table, adding one is adding a row, which is
+why tool calling extends to anything a function can do.</a:t>
             </a:r>
             <a:endParaRPr lang="en-US" dirty="0"/>
           </a:p>
@@ -2902,7 +2906,557 @@
 </p:notes>
 </file>
 
-<file path=ppt/notesSlides/notesSlide4.xml><?xml version="1.0" encoding="utf-8"?>
+<file path=ppt/notesSlides/notesSlide33.xml><?xml version="1.0" encoding="utf-8"?>
+<p:notes xmlns:a="http://schemas.openxmlformats.org/drawingml/2006/main" xmlns:r="http://schemas.openxmlformats.org/officeDocument/2006/relationships" xmlns:p="http://schemas.openxmlformats.org/presentationml/2006/main">
+  <p:cSld>
+    <p:spTree>
+      <p:nvGrpSpPr>
+        <p:cNvPr id="1" name=""/>
+        <p:cNvGrpSpPr/>
+        <p:nvPr/>
+      </p:nvGrpSpPr>
+      <p:grpSpPr>
+        <a:xfrm>
+          <a:off x="0" y="0"/>
+          <a:ext cx="0" cy="0"/>
+          <a:chOff x="0" y="0"/>
+          <a:chExt cx="0" cy="0"/>
+        </a:xfrm>
+      </p:grpSpPr>
+      <p:sp>
+        <p:nvSpPr>
+          <p:cNvPr id="2" name="Slide Image Placeholder 1"/>
+          <p:cNvSpPr>
+            <a:spLocks noGrp="1" noRot="1" noChangeAspect="1"/>
+          </p:cNvSpPr>
+          <p:nvPr>
+            <p:ph type="sldImg"/>
+          </p:nvPr>
+        </p:nvSpPr>
+        <p:spPr/>
+      </p:sp>
+      <p:sp>
+        <p:nvSpPr>
+          <p:cNvPr id="3" name="Notes Placeholder 2"/>
+          <p:cNvSpPr>
+            <a:spLocks noGrp="1"/>
+          </p:cNvSpPr>
+          <p:nvPr>
+            <p:ph type="body" idx="1"/>
+          </p:nvPr>
+        </p:nvSpPr>
+        <p:spPr/>
+        <p:txBody>
+          <a:bodyPr/>
+          <a:lstStyle/>
+          <a:p>
+            <a:r>
+              <a:rPr lang="en-US" dirty="0"/>
+              <a:t>The sentence to carry out of this part. The model emits text. Every read, every
+command, every write is executed by code the student wrote, and that code can
+say no.</a:t>
+            </a:r>
+            <a:endParaRPr lang="en-US" dirty="0"/>
+          </a:p>
+        </p:txBody>
+      </p:sp>
+      <p:sp>
+        <p:nvSpPr>
+          <p:cNvPr id="4" name="Slide Number Placeholder 3"/>
+          <p:cNvSpPr>
+            <a:spLocks noGrp="1"/>
+          </p:cNvSpPr>
+          <p:nvPr>
+            <p:ph type="sldNum" sz="quarter" idx="10"/>
+          </p:nvPr>
+        </p:nvSpPr>
+        <p:spPr/>
+        <p:txBody>
+          <a:bodyPr/>
+          <a:lstStyle/>
+          <a:p>
+            <a:fld id="{F7021451-1387-4CA6-816F-3879F97B5CBC}" type="slidenum">
+              <a:rPr lang="en-US"/>
+              <a:t>33</a:t>
+            </a:fld>
+            <a:endParaRPr lang="en-US"/>
+          </a:p>
+        </p:txBody>
+      </p:sp>
+    </p:spTree>
+    <p:extLst>
+      <p:ext uri="{BB962C8B-B14F-4D97-AF65-F5344CB8AC3E}">
+        <p14:creationId xmlns:p14="http://schemas.microsoft.com/office/powerpoint/2010/main" val="1024086991"/>
+      </p:ext>
+    </p:extLst>
+  </p:cSld>
+  <p:clrMapOvr>
+    <a:masterClrMapping/>
+  </p:clrMapOvr>
+</p:notes>
+</file>
+
+<file path=ppt/notesSlides/notesSlide34.xml><?xml version="1.0" encoding="utf-8"?>
+<p:notes xmlns:a="http://schemas.openxmlformats.org/drawingml/2006/main" xmlns:r="http://schemas.openxmlformats.org/officeDocument/2006/relationships" xmlns:p="http://schemas.openxmlformats.org/presentationml/2006/main">
+  <p:cSld>
+    <p:spTree>
+      <p:nvGrpSpPr>
+        <p:cNvPr id="1" name=""/>
+        <p:cNvGrpSpPr/>
+        <p:nvPr/>
+      </p:nvGrpSpPr>
+      <p:grpSpPr>
+        <a:xfrm>
+          <a:off x="0" y="0"/>
+          <a:ext cx="0" cy="0"/>
+          <a:chOff x="0" y="0"/>
+          <a:chExt cx="0" cy="0"/>
+        </a:xfrm>
+      </p:grpSpPr>
+      <p:sp>
+        <p:nvSpPr>
+          <p:cNvPr id="2" name="Slide Image Placeholder 1"/>
+          <p:cNvSpPr>
+            <a:spLocks noGrp="1" noRot="1" noChangeAspect="1"/>
+          </p:cNvSpPr>
+          <p:nvPr>
+            <p:ph type="sldImg"/>
+          </p:nvPr>
+        </p:nvSpPr>
+        <p:spPr/>
+      </p:sp>
+      <p:sp>
+        <p:nvSpPr>
+          <p:cNvPr id="3" name="Notes Placeholder 2"/>
+          <p:cNvSpPr>
+            <a:spLocks noGrp="1"/>
+          </p:cNvSpPr>
+          <p:nvPr>
+            <p:ph type="body" idx="1"/>
+          </p:nvPr>
+        </p:nvSpPr>
+        <p:spPr/>
+        <p:txBody>
+          <a:bodyPr/>
+          <a:lstStyle/>
+          <a:p>
+            <a:r>
+              <a:rPr lang="en-US" dirty="0"/>
+              <a:t>With READ and RUN added but nothing else changed, this is what a session looks
+like. The model asks, the harness acts, and then a person has to send the result
+back and say continue.
+That person is doing no thinking. They are a loop with a keyboard. So automate
+them.</a:t>
+            </a:r>
+            <a:endParaRPr lang="en-US" dirty="0"/>
+          </a:p>
+        </p:txBody>
+      </p:sp>
+      <p:sp>
+        <p:nvSpPr>
+          <p:cNvPr id="4" name="Slide Number Placeholder 3"/>
+          <p:cNvSpPr>
+            <a:spLocks noGrp="1"/>
+          </p:cNvSpPr>
+          <p:nvPr>
+            <p:ph type="sldNum" sz="quarter" idx="10"/>
+          </p:nvPr>
+        </p:nvSpPr>
+        <p:spPr/>
+        <p:txBody>
+          <a:bodyPr/>
+          <a:lstStyle/>
+          <a:p>
+            <a:fld id="{F7021451-1387-4CA6-816F-3879F97B5CBC}" type="slidenum">
+              <a:rPr lang="en-US"/>
+              <a:t>34</a:t>
+            </a:fld>
+            <a:endParaRPr lang="en-US"/>
+          </a:p>
+        </p:txBody>
+      </p:sp>
+    </p:spTree>
+    <p:extLst>
+      <p:ext uri="{BB962C8B-B14F-4D97-AF65-F5344CB8AC3E}">
+        <p14:creationId xmlns:p14="http://schemas.microsoft.com/office/powerpoint/2010/main" val="1024086991"/>
+      </p:ext>
+    </p:extLst>
+  </p:cSld>
+  <p:clrMapOvr>
+    <a:masterClrMapping/>
+  </p:clrMapOvr>
+</p:notes>
+</file>
+
+<file path=ppt/notesSlides/notesSlide35.xml><?xml version="1.0" encoding="utf-8"?>
+<p:notes xmlns:a="http://schemas.openxmlformats.org/drawingml/2006/main" xmlns:r="http://schemas.openxmlformats.org/officeDocument/2006/relationships" xmlns:p="http://schemas.openxmlformats.org/presentationml/2006/main">
+  <p:cSld>
+    <p:spTree>
+      <p:nvGrpSpPr>
+        <p:cNvPr id="1" name=""/>
+        <p:cNvGrpSpPr/>
+        <p:nvPr/>
+      </p:nvGrpSpPr>
+      <p:grpSpPr>
+        <a:xfrm>
+          <a:off x="0" y="0"/>
+          <a:ext cx="0" cy="0"/>
+          <a:chOff x="0" y="0"/>
+          <a:chExt cx="0" cy="0"/>
+        </a:xfrm>
+      </p:grpSpPr>
+      <p:sp>
+        <p:nvSpPr>
+          <p:cNvPr id="2" name="Slide Image Placeholder 1"/>
+          <p:cNvSpPr>
+            <a:spLocks noGrp="1" noRot="1" noChangeAspect="1"/>
+          </p:cNvSpPr>
+          <p:nvPr>
+            <p:ph type="sldImg"/>
+          </p:nvPr>
+        </p:nvSpPr>
+        <p:spPr/>
+      </p:sp>
+      <p:sp>
+        <p:nvSpPr>
+          <p:cNvPr id="3" name="Notes Placeholder 2"/>
+          <p:cNvSpPr>
+            <a:spLocks noGrp="1"/>
+          </p:cNvSpPr>
+          <p:nvPr>
+            <p:ph type="body" idx="1"/>
+          </p:nvPr>
+        </p:nvSpPr>
+        <p:spPr/>
+        <p:txBody>
+          <a:bodyPr/>
+          <a:lstStyle/>
+          <a:p>
+            <a:r>
+              <a:rPr lang="en-US" dirty="0"/>
+              <a:t>Six lines, and the "keep going" is gone. Nothing in there says which file to
+read, what the next step is, or when to stop. The model supplies all three from
+a request the user typed once.
+That is an agent. It is the dispatcher from four slides ago with the person
+replaced by while True.</a:t>
+            </a:r>
+            <a:endParaRPr lang="en-US" dirty="0"/>
+          </a:p>
+        </p:txBody>
+      </p:sp>
+      <p:sp>
+        <p:nvSpPr>
+          <p:cNvPr id="4" name="Slide Number Placeholder 3"/>
+          <p:cNvSpPr>
+            <a:spLocks noGrp="1"/>
+          </p:cNvSpPr>
+          <p:nvPr>
+            <p:ph type="sldNum" sz="quarter" idx="10"/>
+          </p:nvPr>
+        </p:nvSpPr>
+        <p:spPr/>
+        <p:txBody>
+          <a:bodyPr/>
+          <a:lstStyle/>
+          <a:p>
+            <a:fld id="{F7021451-1387-4CA6-816F-3879F97B5CBC}" type="slidenum">
+              <a:rPr lang="en-US"/>
+              <a:t>35</a:t>
+            </a:fld>
+            <a:endParaRPr lang="en-US"/>
+          </a:p>
+        </p:txBody>
+      </p:sp>
+    </p:spTree>
+    <p:extLst>
+      <p:ext uri="{BB962C8B-B14F-4D97-AF65-F5344CB8AC3E}">
+        <p14:creationId xmlns:p14="http://schemas.microsoft.com/office/powerpoint/2010/main" val="1024086991"/>
+      </p:ext>
+    </p:extLst>
+  </p:cSld>
+  <p:clrMapOvr>
+    <a:masterClrMapping/>
+  </p:clrMapOvr>
+</p:notes>
+</file>
+
+<file path=ppt/notesSlides/notesSlide36.xml><?xml version="1.0" encoding="utf-8"?>
+<p:notes xmlns:a="http://schemas.openxmlformats.org/drawingml/2006/main" xmlns:r="http://schemas.openxmlformats.org/officeDocument/2006/relationships" xmlns:p="http://schemas.openxmlformats.org/presentationml/2006/main">
+  <p:cSld>
+    <p:spTree>
+      <p:nvGrpSpPr>
+        <p:cNvPr id="1" name=""/>
+        <p:cNvGrpSpPr/>
+        <p:nvPr/>
+      </p:nvGrpSpPr>
+      <p:grpSpPr>
+        <a:xfrm>
+          <a:off x="0" y="0"/>
+          <a:ext cx="0" cy="0"/>
+          <a:chOff x="0" y="0"/>
+          <a:chExt cx="0" cy="0"/>
+        </a:xfrm>
+      </p:grpSpPr>
+      <p:sp>
+        <p:nvSpPr>
+          <p:cNvPr id="2" name="Slide Image Placeholder 1"/>
+          <p:cNvSpPr>
+            <a:spLocks noGrp="1" noRot="1" noChangeAspect="1"/>
+          </p:cNvSpPr>
+          <p:nvPr>
+            <p:ph type="sldImg"/>
+          </p:nvPr>
+        </p:nvSpPr>
+        <p:spPr/>
+      </p:sp>
+      <p:sp>
+        <p:nvSpPr>
+          <p:cNvPr id="3" name="Notes Placeholder 2"/>
+          <p:cNvSpPr>
+            <a:spLocks noGrp="1"/>
+          </p:cNvSpPr>
+          <p:nvPr>
+            <p:ph type="body" idx="1"/>
+          </p:nvPr>
+        </p:nvSpPr>
+        <p:spPr/>
+        <p:txBody>
+          <a:bodyPr/>
+          <a:lstStyle/>
+          <a:p>
+            <a:r>
+              <a:rPr lang="en-US" dirty="0"/>
+              <a:t>The loop can look like handing over control. It is narrower than that. The model
+still produces nothing but text. Every read, run and edit is still code the
+student wrote, and that code can refuse. The one thing that moved is who decides
+what happens next: in their Stage 1 program, the person; in the loop, the model.</a:t>
+            </a:r>
+            <a:endParaRPr lang="en-US" dirty="0"/>
+          </a:p>
+        </p:txBody>
+      </p:sp>
+      <p:sp>
+        <p:nvSpPr>
+          <p:cNvPr id="4" name="Slide Number Placeholder 3"/>
+          <p:cNvSpPr>
+            <a:spLocks noGrp="1"/>
+          </p:cNvSpPr>
+          <p:nvPr>
+            <p:ph type="sldNum" sz="quarter" idx="10"/>
+          </p:nvPr>
+        </p:nvSpPr>
+        <p:spPr/>
+        <p:txBody>
+          <a:bodyPr/>
+          <a:lstStyle/>
+          <a:p>
+            <a:fld id="{F7021451-1387-4CA6-816F-3879F97B5CBC}" type="slidenum">
+              <a:rPr lang="en-US"/>
+              <a:t>36</a:t>
+            </a:fld>
+            <a:endParaRPr lang="en-US"/>
+          </a:p>
+        </p:txBody>
+      </p:sp>
+    </p:spTree>
+    <p:extLst>
+      <p:ext uri="{BB962C8B-B14F-4D97-AF65-F5344CB8AC3E}">
+        <p14:creationId xmlns:p14="http://schemas.microsoft.com/office/powerpoint/2010/main" val="1024086991"/>
+      </p:ext>
+    </p:extLst>
+  </p:cSld>
+  <p:clrMapOvr>
+    <a:masterClrMapping/>
+  </p:clrMapOvr>
+</p:notes>
+</file>
+
+<file path=ppt/notesSlides/notesSlide37.xml><?xml version="1.0" encoding="utf-8"?>
+<p:notes xmlns:a="http://schemas.openxmlformats.org/drawingml/2006/main" xmlns:r="http://schemas.openxmlformats.org/officeDocument/2006/relationships" xmlns:p="http://schemas.openxmlformats.org/presentationml/2006/main">
+  <p:cSld>
+    <p:spTree>
+      <p:nvGrpSpPr>
+        <p:cNvPr id="1" name=""/>
+        <p:cNvGrpSpPr/>
+        <p:nvPr/>
+      </p:nvGrpSpPr>
+      <p:grpSpPr>
+        <a:xfrm>
+          <a:off x="0" y="0"/>
+          <a:ext cx="0" cy="0"/>
+          <a:chOff x="0" y="0"/>
+          <a:chExt cx="0" cy="0"/>
+        </a:xfrm>
+      </p:grpSpPr>
+      <p:sp>
+        <p:nvSpPr>
+          <p:cNvPr id="2" name="Slide Image Placeholder 1"/>
+          <p:cNvSpPr>
+            <a:spLocks noGrp="1" noRot="1" noChangeAspect="1"/>
+          </p:cNvSpPr>
+          <p:nvPr>
+            <p:ph type="sldImg"/>
+          </p:nvPr>
+        </p:nvSpPr>
+        <p:spPr/>
+      </p:sp>
+      <p:sp>
+        <p:nvSpPr>
+          <p:cNvPr id="3" name="Notes Placeholder 2"/>
+          <p:cNvSpPr>
+            <a:spLocks noGrp="1"/>
+          </p:cNvSpPr>
+          <p:nvPr>
+            <p:ph type="body" idx="1"/>
+          </p:nvPr>
+        </p:nvSpPr>
+        <p:spPr/>
+        <p:txBody>
+          <a:bodyPr/>
+          <a:lstStyle/>
+          <a:p>
+            <a:r>
+              <a:rPr lang="en-US" dirty="0"/>
+              <a:t>A loop that runs until the model says it is done will sometimes never be done.
+Same call, same arguments, forever. Or it decides it finished when it did not.
+So stop conditions become code rather than a key the user presses.
+And RUN is the command their safety net does not cover. /undo is a git
+operation, and git does not undo rm -rf, a package install, or anything outside
+the repository. Their Stage 1 program already asks before it writes a file. The
+agent has to ask before it runs a command.
+That is Analyze. Do not go further today.</a:t>
+            </a:r>
+            <a:endParaRPr lang="en-US" dirty="0"/>
+          </a:p>
+        </p:txBody>
+      </p:sp>
+      <p:sp>
+        <p:nvSpPr>
+          <p:cNvPr id="4" name="Slide Number Placeholder 3"/>
+          <p:cNvSpPr>
+            <a:spLocks noGrp="1"/>
+          </p:cNvSpPr>
+          <p:nvPr>
+            <p:ph type="sldNum" sz="quarter" idx="10"/>
+          </p:nvPr>
+        </p:nvSpPr>
+        <p:spPr/>
+        <p:txBody>
+          <a:bodyPr/>
+          <a:lstStyle/>
+          <a:p>
+            <a:fld id="{F7021451-1387-4CA6-816F-3879F97B5CBC}" type="slidenum">
+              <a:rPr lang="en-US"/>
+              <a:t>37</a:t>
+            </a:fld>
+            <a:endParaRPr lang="en-US"/>
+          </a:p>
+        </p:txBody>
+      </p:sp>
+    </p:spTree>
+    <p:extLst>
+      <p:ext uri="{BB962C8B-B14F-4D97-AF65-F5344CB8AC3E}">
+        <p14:creationId xmlns:p14="http://schemas.microsoft.com/office/powerpoint/2010/main" val="1024086991"/>
+      </p:ext>
+    </p:extLst>
+  </p:cSld>
+  <p:clrMapOvr>
+    <a:masterClrMapping/>
+  </p:clrMapOvr>
+</p:notes>
+</file>
+
+<file path=ppt/notesSlides/notesSlide38.xml><?xml version="1.0" encoding="utf-8"?>
+<p:notes xmlns:a="http://schemas.openxmlformats.org/drawingml/2006/main" xmlns:r="http://schemas.openxmlformats.org/officeDocument/2006/relationships" xmlns:p="http://schemas.openxmlformats.org/presentationml/2006/main">
+  <p:cSld>
+    <p:spTree>
+      <p:nvGrpSpPr>
+        <p:cNvPr id="1" name=""/>
+        <p:cNvGrpSpPr/>
+        <p:nvPr/>
+      </p:nvGrpSpPr>
+      <p:grpSpPr>
+        <a:xfrm>
+          <a:off x="0" y="0"/>
+          <a:ext cx="0" cy="0"/>
+          <a:chOff x="0" y="0"/>
+          <a:chExt cx="0" cy="0"/>
+        </a:xfrm>
+      </p:grpSpPr>
+      <p:sp>
+        <p:nvSpPr>
+          <p:cNvPr id="2" name="Slide Image Placeholder 1"/>
+          <p:cNvSpPr>
+            <a:spLocks noGrp="1" noRot="1" noChangeAspect="1"/>
+          </p:cNvSpPr>
+          <p:nvPr>
+            <p:ph type="sldImg"/>
+          </p:nvPr>
+        </p:nvSpPr>
+        <p:spPr/>
+      </p:sp>
+      <p:sp>
+        <p:nvSpPr>
+          <p:cNvPr id="3" name="Notes Placeholder 2"/>
+          <p:cNvSpPr>
+            <a:spLocks noGrp="1"/>
+          </p:cNvSpPr>
+          <p:nvPr>
+            <p:ph type="body" idx="1"/>
+          </p:nvPr>
+        </p:nvSpPr>
+        <p:spPr/>
+        <p:txBody>
+          <a:bodyPr/>
+          <a:lstStyle/>
+          <a:p>
+            <a:r>
+              <a:rPr lang="en-US" dirty="0"/>
+              <a:t>Say the order out loud. Read, design, review, then increments.
+The build is where they practice the middle of today: name their own
+acceptance criteria, prompt Aider by those names, and check what comes back.</a:t>
+            </a:r>
+            <a:endParaRPr lang="en-US" dirty="0"/>
+          </a:p>
+        </p:txBody>
+      </p:sp>
+      <p:sp>
+        <p:nvSpPr>
+          <p:cNvPr id="4" name="Slide Number Placeholder 3"/>
+          <p:cNvSpPr>
+            <a:spLocks noGrp="1"/>
+          </p:cNvSpPr>
+          <p:nvPr>
+            <p:ph type="sldNum" sz="quarter" idx="10"/>
+          </p:nvPr>
+        </p:nvSpPr>
+        <p:spPr/>
+        <p:txBody>
+          <a:bodyPr/>
+          <a:lstStyle/>
+          <a:p>
+            <a:fld id="{F7021451-1387-4CA6-816F-3879F97B5CBC}" type="slidenum">
+              <a:rPr lang="en-US"/>
+              <a:t>38</a:t>
+            </a:fld>
+            <a:endParaRPr lang="en-US"/>
+          </a:p>
+        </p:txBody>
+      </p:sp>
+    </p:spTree>
+    <p:extLst>
+      <p:ext uri="{BB962C8B-B14F-4D97-AF65-F5344CB8AC3E}">
+        <p14:creationId xmlns:p14="http://schemas.microsoft.com/office/powerpoint/2010/main" val="1024086991"/>
+      </p:ext>
+    </p:extLst>
+  </p:cSld>
+  <p:clrMapOvr>
+    <a:masterClrMapping/>
+  </p:clrMapOvr>
+</p:notes>
+</file>
+
+<file path=ppt/notesSlides/notesSlide39.xml><?xml version="1.0" encoding="utf-8"?>
 <p:notes xmlns:a="http://schemas.openxmlformats.org/drawingml/2006/main" xmlns:r="http://schemas.openxmlformats.org/officeDocument/2006/relationships" xmlns:p="http://schemas.openxmlformats.org/presentationml/2006/main">
   <p:cSld>
     <p:spTree>
@@ -2971,7 +3525,7 @@
           <a:p>
             <a:fld id="{F7021451-1387-4CA6-816F-3879F97B5CBC}" type="slidenum">
               <a:rPr lang="en-US"/>
-              <a:t>4</a:t>
+              <a:t>39</a:t>
             </a:fld>
             <a:endParaRPr lang="en-US"/>
           </a:p>
@@ -2990,6 +3544,104 @@
 </p:notes>
 </file>
 
+<file path=ppt/notesSlides/notesSlide4.xml><?xml version="1.0" encoding="utf-8"?>
+<p:notes xmlns:a="http://schemas.openxmlformats.org/drawingml/2006/main" xmlns:r="http://schemas.openxmlformats.org/officeDocument/2006/relationships" xmlns:p="http://schemas.openxmlformats.org/presentationml/2006/main">
+  <p:cSld>
+    <p:spTree>
+      <p:nvGrpSpPr>
+        <p:cNvPr id="1" name=""/>
+        <p:cNvGrpSpPr/>
+        <p:nvPr/>
+      </p:nvGrpSpPr>
+      <p:grpSpPr>
+        <a:xfrm>
+          <a:off x="0" y="0"/>
+          <a:ext cx="0" cy="0"/>
+          <a:chOff x="0" y="0"/>
+          <a:chExt cx="0" cy="0"/>
+        </a:xfrm>
+      </p:grpSpPr>
+      <p:sp>
+        <p:nvSpPr>
+          <p:cNvPr id="2" name="Slide Image Placeholder 1"/>
+          <p:cNvSpPr>
+            <a:spLocks noGrp="1" noRot="1" noChangeAspect="1"/>
+          </p:cNvSpPr>
+          <p:nvPr>
+            <p:ph type="sldImg"/>
+          </p:nvPr>
+        </p:nvSpPr>
+        <p:spPr/>
+      </p:sp>
+      <p:sp>
+        <p:nvSpPr>
+          <p:cNvPr id="3" name="Notes Placeholder 2"/>
+          <p:cNvSpPr>
+            <a:spLocks noGrp="1"/>
+          </p:cNvSpPr>
+          <p:nvPr>
+            <p:ph type="body" idx="1"/>
+          </p:nvPr>
+        </p:nvSpPr>
+        <p:spPr/>
+        <p:txBody>
+          <a:bodyPr/>
+          <a:lstStyle/>
+          <a:p>
+            <a:r>
+              <a:rPr lang="en-US" dirty="0"/>
+              <a:t>Keep this general. They have used Aider for three weeks, so they already know
+what a pair-programmer does: you pick files, ask for a change, read the diff,
+and it lands in git. They are now writing a small one of their own, in Python,
+against a model endpoint.
+It works on a separate target repository, never the one it lives in.
+What it deliberately does not do: find files on its own, run commands, or
+choose its next step. Hold on to that. The last part of today adds exactly
+those things.
+They build it with Aider, and it never calls Aider. Tell them to read
+EXAMPLES.md before anything else. It shows the finished program session by
+session.</a:t>
+            </a:r>
+            <a:endParaRPr lang="en-US" dirty="0"/>
+          </a:p>
+        </p:txBody>
+      </p:sp>
+      <p:sp>
+        <p:nvSpPr>
+          <p:cNvPr id="4" name="Slide Number Placeholder 3"/>
+          <p:cNvSpPr>
+            <a:spLocks noGrp="1"/>
+          </p:cNvSpPr>
+          <p:nvPr>
+            <p:ph type="sldNum" sz="quarter" idx="10"/>
+          </p:nvPr>
+        </p:nvSpPr>
+        <p:spPr/>
+        <p:txBody>
+          <a:bodyPr/>
+          <a:lstStyle/>
+          <a:p>
+            <a:fld id="{F7021451-1387-4CA6-816F-3879F97B5CBC}" type="slidenum">
+              <a:rPr lang="en-US"/>
+              <a:t>4</a:t>
+            </a:fld>
+            <a:endParaRPr lang="en-US"/>
+          </a:p>
+        </p:txBody>
+      </p:sp>
+    </p:spTree>
+    <p:extLst>
+      <p:ext uri="{BB962C8B-B14F-4D97-AF65-F5344CB8AC3E}">
+        <p14:creationId xmlns:p14="http://schemas.microsoft.com/office/powerpoint/2010/main" val="1024086991"/>
+      </p:ext>
+    </p:extLst>
+  </p:cSld>
+  <p:clrMapOvr>
+    <a:masterClrMapping/>
+  </p:clrMapOvr>
+</p:notes>
+</file>
+
 <file path=ppt/notesSlides/notesSlide5.xml><?xml version="1.0" encoding="utf-8"?>
 <p:notes xmlns:a="http://schemas.openxmlformats.org/drawingml/2006/main" xmlns:r="http://schemas.openxmlformats.org/officeDocument/2006/relationships" xmlns:p="http://schemas.openxmlformats.org/presentationml/2006/main">
   <p:cSld>
@@ -3036,21 +3688,15 @@
           <a:p>
             <a:r>
               <a:rPr lang="en-US" dirty="0"/>
-              <a:t>Resist "Aider is not agentic." Tuesday already rejected that, and they will
-remember. Aider has a loop, tools, planning in architect mode, and session
-state.
-Fixed means the repertoire was decided when the program was written, not when
-it ran: edit, resend a miss up to three times (the number Lab01 gave them), run
-the configured tests, plan first in architect mode. On the third try it has the
-moves it had on the first. Shallow means nothing in a turn is chosen because of
-something discovered two steps earlier, since there are no two steps earlier;
-the offer to add a file (L03) routes through their yes, and the repo map
-(Lab01) is a fixed ranking rule. Human-framed: Aider writes and commits before
-asking, so for two weeks the turn ended at the commit and their /undo. L01 put
-Aider in the third wave, a tool that reads and keeps going; finish the sentence
-for them: inside a boundary they drew.
-None of the three is an insult. A pair-programmer that narrowed its own scope
-would be a worse pair-programmer.</a:t>
+              <a:t>The starter is an echo loop in assistant/cli.py with /quit wired up. It is a
+place to begin, not a design they must keep.
+The packet is less specific than they might expect, and that is on purpose.
+SPEC.md says what the program does from the outside. Everything on the right is
+theirs, and the rubric's requirements row pays for settling those decisions,
+not for restating the spec. There is no prescribed architecture and no hidden
+test suite.
+This matters for the middle of today. When the spec does not name a decision,
+they have to, and a name is what lets them and the model talk about it.</a:t>
             </a:r>
             <a:endParaRPr lang="en-US" dirty="0"/>
           </a:p>
@@ -3138,14 +3784,15 @@
           <a:p>
             <a:r>
               <a:rPr lang="en-US" dirty="0"/>
-              <a:t>This is the slide the lecture turns on. Put SPEC.md on the screen and read the
-lines; they get their own copy tonight.
-Section 1's "what this program is not" is a fixed repertoire written down as a
-requirement: the list of things it will not do is longer than the list it will.
-F1.4 makes every request the same three things and F5.1 parses one complete
-reply; F1.5 trims rather than reads when the budget is hit. Shallower than
-Aider: no repo map, no offer to add a file. Their program is more human-framed
-than the tool they are building it with.</a:t>
+              <a:t>Step 2: design/SYSTEM.md and three diagrams (components and data flow, one
+request sequence, the edit lifecycle), using DESIGN-GUIDE.md as the checklist.
+Then a fresh Aider session reviews the document without the chat that drafted
+it. That is the fastest way to find what is missing.
+Step 3: an increment spec in specs/ before each increment, from the five-section
+template. Load only the files that increment needs and verify before moving on.
+Try the program on a disposable target repository, never on this one.
+Step 4: the live edit-prompt protocol in ACCEPTANCE.md with every attempt
+recorded, USAGE.md, REFLECTION.md, and diagrams updated to match what they built.</a:t>
             </a:r>
             <a:endParaRPr lang="en-US" dirty="0"/>
           </a:p>
@@ -3233,15 +3880,14 @@
           <a:p>
             <a:r>
               <a:rPr lang="en-US" dirty="0"/>
-              <a:t>Pause here. They do not think of it as an approval layer and it is exactly one,
-and it is one Aider does not have: Aider writes and commits, and /undo is the
-recovery.
-F5.4, F6.2 and F6.7 make it a mechanism rather than a request: a block naming a
-file outside the selected set is rejected however confidently the model asked,
-and F4.4 says the prompt is not what enforces it. Their program is
-constitutionally incapable of changing a file they did not put in front of it
-and did not say yes to. Hold that thought for forty minutes; the second half is
-what happens to it when a shell arrives.</a:t>
+              <a:t>Half the grade is the writing. Requirements, architecture, increment specs, the
+three diagrams, specs-before-code and the reflection.
+Specs before code is scored from git history, so the order they commit in is
+evidence.
+No points for suffering is the rubric's own phrase. More prompts, more failures
+and longer logs earn nothing. An efficient workflow that succeeds can earn full
+marks. Tests for unfinished features stay in the suite as strict xfail, never
+deleted or weakened.</a:t>
             </a:r>
             <a:endParaRPr lang="en-US" dirty="0"/>
           </a:p>
@@ -3329,16 +3975,13 @@
           <a:p>
             <a:r>
               <a:rPr lang="en-US" dirty="0"/>
-              <a:t>Strip the vocabulary away and this is all a pair-programmer is. One is L03's
-context lever; two is its prompt lever, one bounded task per turn, which
-Tuesday called where the task ends; three is the commit and /undo for Aider,
-and the yes or no at the prompt for their build.
-Lab01's harness table had four rows: what the model sees, what happens to a
-reply, what comes next, what survives the session. These are the first three
-from the person's side; the fourth is on v0's exclusion list.
-Number two is today. Taking it away forces the other two: a program choosing
-its next step has to choose what to read (a search problem) and when it is
-finished (a stop-condition problem).</a:t>
+              <a:t>Hackathon 1 is a separate two-hour assessment on a supplied application. It does
+not need a finished build.
+Late work loses 10% per day for three days. Push. A commit that exists only on a
+laptop is not submitted.
+The same repository carries through Analyze and Create, so preserve the history.
+Aider does not commit .aider.chat.history.md, so they commit it themselves at
+the end of each session, and never add it to Aider's editable context.</a:t>
             </a:r>
             <a:endParaRPr lang="en-US" dirty="0"/>
           </a:p>
@@ -3426,16 +4069,7 @@
           <a:p>
             <a:r>
               <a:rPr lang="en-US" dirty="0"/>
-              <a:t>Say it and leave it up for a beat.
-They still type the goal. What they stop supplying is the next step. Not new
-intelligence, not a better model (L03: the failure was never the model, and the
-fix is not the model either). The same model, handed a set of actions and a
-loop that lets it pick the next one, behaves like a different category of
-software.
-If someone says L04's architect run already did this: they pasted a whole spec
-and read the result, but the spec listed its steps in order so the model would
-not have to discover them. Decision two, supplied in advance. An agent
-discovers the order as it goes.</a:t>
+              <a:t/>
             </a:r>
             <a:endParaRPr lang="en-US" dirty="0"/>
           </a:p>
@@ -4762,6 +5396,279 @@
 <file path=ppt/slides/slide32.xml><?xml version="1.0" encoding="utf-8"?>
 <p:sld xmlns:a="http://schemas.openxmlformats.org/drawingml/2006/main" xmlns:r="http://schemas.openxmlformats.org/officeDocument/2006/relationships" xmlns:p="http://schemas.openxmlformats.org/presentationml/2006/main">
   <p:cSld name="Slide 32">
+    <p:bg>
+      <p:bgPr>
+        <a:blipFill dpi="0" rotWithShape="1">
+          <a:blip r:embed="rId1">
+            <a:lum/>
+          </a:blip>
+          <a:srcRect/>
+          <a:stretch>
+            <a:fillRect/>
+          </a:stretch>
+        </a:blipFill>
+        <a:effectLst/>
+      </p:bgPr>
+    </p:bg>
+    <p:spTree>
+      <p:nvGrpSpPr>
+        <p:cNvPr id="1" name=""/>
+        <p:cNvGrpSpPr/>
+        <p:nvPr/>
+      </p:nvGrpSpPr>
+      <p:grpSpPr>
+        <a:xfrm>
+          <a:off x="0" y="0"/>
+          <a:ext cx="0" cy="0"/>
+          <a:chOff x="0" y="0"/>
+          <a:chExt cx="0" cy="0"/>
+        </a:xfrm>
+      </p:grpSpPr>
+    </p:spTree>
+  </p:cSld>
+  <p:clrMapOvr>
+    <a:masterClrMapping/>
+  </p:clrMapOvr>
+</p:sld>
+</file>
+
+<file path=ppt/slides/slide33.xml><?xml version="1.0" encoding="utf-8"?>
+<p:sld xmlns:a="http://schemas.openxmlformats.org/drawingml/2006/main" xmlns:r="http://schemas.openxmlformats.org/officeDocument/2006/relationships" xmlns:p="http://schemas.openxmlformats.org/presentationml/2006/main">
+  <p:cSld name="Slide 33">
+    <p:bg>
+      <p:bgPr>
+        <a:blipFill dpi="0" rotWithShape="1">
+          <a:blip r:embed="rId1">
+            <a:lum/>
+          </a:blip>
+          <a:srcRect/>
+          <a:stretch>
+            <a:fillRect/>
+          </a:stretch>
+        </a:blipFill>
+        <a:effectLst/>
+      </p:bgPr>
+    </p:bg>
+    <p:spTree>
+      <p:nvGrpSpPr>
+        <p:cNvPr id="1" name=""/>
+        <p:cNvGrpSpPr/>
+        <p:nvPr/>
+      </p:nvGrpSpPr>
+      <p:grpSpPr>
+        <a:xfrm>
+          <a:off x="0" y="0"/>
+          <a:ext cx="0" cy="0"/>
+          <a:chOff x="0" y="0"/>
+          <a:chExt cx="0" cy="0"/>
+        </a:xfrm>
+      </p:grpSpPr>
+    </p:spTree>
+  </p:cSld>
+  <p:clrMapOvr>
+    <a:masterClrMapping/>
+  </p:clrMapOvr>
+</p:sld>
+</file>
+
+<file path=ppt/slides/slide34.xml><?xml version="1.0" encoding="utf-8"?>
+<p:sld xmlns:a="http://schemas.openxmlformats.org/drawingml/2006/main" xmlns:r="http://schemas.openxmlformats.org/officeDocument/2006/relationships" xmlns:p="http://schemas.openxmlformats.org/presentationml/2006/main">
+  <p:cSld name="Slide 34">
+    <p:bg>
+      <p:bgPr>
+        <a:blipFill dpi="0" rotWithShape="1">
+          <a:blip r:embed="rId1">
+            <a:lum/>
+          </a:blip>
+          <a:srcRect/>
+          <a:stretch>
+            <a:fillRect/>
+          </a:stretch>
+        </a:blipFill>
+        <a:effectLst/>
+      </p:bgPr>
+    </p:bg>
+    <p:spTree>
+      <p:nvGrpSpPr>
+        <p:cNvPr id="1" name=""/>
+        <p:cNvGrpSpPr/>
+        <p:nvPr/>
+      </p:nvGrpSpPr>
+      <p:grpSpPr>
+        <a:xfrm>
+          <a:off x="0" y="0"/>
+          <a:ext cx="0" cy="0"/>
+          <a:chOff x="0" y="0"/>
+          <a:chExt cx="0" cy="0"/>
+        </a:xfrm>
+      </p:grpSpPr>
+    </p:spTree>
+  </p:cSld>
+  <p:clrMapOvr>
+    <a:masterClrMapping/>
+  </p:clrMapOvr>
+</p:sld>
+</file>
+
+<file path=ppt/slides/slide35.xml><?xml version="1.0" encoding="utf-8"?>
+<p:sld xmlns:a="http://schemas.openxmlformats.org/drawingml/2006/main" xmlns:r="http://schemas.openxmlformats.org/officeDocument/2006/relationships" xmlns:p="http://schemas.openxmlformats.org/presentationml/2006/main">
+  <p:cSld name="Slide 35">
+    <p:bg>
+      <p:bgPr>
+        <a:blipFill dpi="0" rotWithShape="1">
+          <a:blip r:embed="rId1">
+            <a:lum/>
+          </a:blip>
+          <a:srcRect/>
+          <a:stretch>
+            <a:fillRect/>
+          </a:stretch>
+        </a:blipFill>
+        <a:effectLst/>
+      </p:bgPr>
+    </p:bg>
+    <p:spTree>
+      <p:nvGrpSpPr>
+        <p:cNvPr id="1" name=""/>
+        <p:cNvGrpSpPr/>
+        <p:nvPr/>
+      </p:nvGrpSpPr>
+      <p:grpSpPr>
+        <a:xfrm>
+          <a:off x="0" y="0"/>
+          <a:ext cx="0" cy="0"/>
+          <a:chOff x="0" y="0"/>
+          <a:chExt cx="0" cy="0"/>
+        </a:xfrm>
+      </p:grpSpPr>
+    </p:spTree>
+  </p:cSld>
+  <p:clrMapOvr>
+    <a:masterClrMapping/>
+  </p:clrMapOvr>
+</p:sld>
+</file>
+
+<file path=ppt/slides/slide36.xml><?xml version="1.0" encoding="utf-8"?>
+<p:sld xmlns:a="http://schemas.openxmlformats.org/drawingml/2006/main" xmlns:r="http://schemas.openxmlformats.org/officeDocument/2006/relationships" xmlns:p="http://schemas.openxmlformats.org/presentationml/2006/main">
+  <p:cSld name="Slide 36">
+    <p:bg>
+      <p:bgPr>
+        <a:blipFill dpi="0" rotWithShape="1">
+          <a:blip r:embed="rId1">
+            <a:lum/>
+          </a:blip>
+          <a:srcRect/>
+          <a:stretch>
+            <a:fillRect/>
+          </a:stretch>
+        </a:blipFill>
+        <a:effectLst/>
+      </p:bgPr>
+    </p:bg>
+    <p:spTree>
+      <p:nvGrpSpPr>
+        <p:cNvPr id="1" name=""/>
+        <p:cNvGrpSpPr/>
+        <p:nvPr/>
+      </p:nvGrpSpPr>
+      <p:grpSpPr>
+        <a:xfrm>
+          <a:off x="0" y="0"/>
+          <a:ext cx="0" cy="0"/>
+          <a:chOff x="0" y="0"/>
+          <a:chExt cx="0" cy="0"/>
+        </a:xfrm>
+      </p:grpSpPr>
+    </p:spTree>
+  </p:cSld>
+  <p:clrMapOvr>
+    <a:masterClrMapping/>
+  </p:clrMapOvr>
+</p:sld>
+</file>
+
+<file path=ppt/slides/slide37.xml><?xml version="1.0" encoding="utf-8"?>
+<p:sld xmlns:a="http://schemas.openxmlformats.org/drawingml/2006/main" xmlns:r="http://schemas.openxmlformats.org/officeDocument/2006/relationships" xmlns:p="http://schemas.openxmlformats.org/presentationml/2006/main">
+  <p:cSld name="Slide 37">
+    <p:bg>
+      <p:bgPr>
+        <a:blipFill dpi="0" rotWithShape="1">
+          <a:blip r:embed="rId1">
+            <a:lum/>
+          </a:blip>
+          <a:srcRect/>
+          <a:stretch>
+            <a:fillRect/>
+          </a:stretch>
+        </a:blipFill>
+        <a:effectLst/>
+      </p:bgPr>
+    </p:bg>
+    <p:spTree>
+      <p:nvGrpSpPr>
+        <p:cNvPr id="1" name=""/>
+        <p:cNvGrpSpPr/>
+        <p:nvPr/>
+      </p:nvGrpSpPr>
+      <p:grpSpPr>
+        <a:xfrm>
+          <a:off x="0" y="0"/>
+          <a:ext cx="0" cy="0"/>
+          <a:chOff x="0" y="0"/>
+          <a:chExt cx="0" cy="0"/>
+        </a:xfrm>
+      </p:grpSpPr>
+    </p:spTree>
+  </p:cSld>
+  <p:clrMapOvr>
+    <a:masterClrMapping/>
+  </p:clrMapOvr>
+</p:sld>
+</file>
+
+<file path=ppt/slides/slide38.xml><?xml version="1.0" encoding="utf-8"?>
+<p:sld xmlns:a="http://schemas.openxmlformats.org/drawingml/2006/main" xmlns:r="http://schemas.openxmlformats.org/officeDocument/2006/relationships" xmlns:p="http://schemas.openxmlformats.org/presentationml/2006/main">
+  <p:cSld name="Slide 38">
+    <p:bg>
+      <p:bgPr>
+        <a:blipFill dpi="0" rotWithShape="1">
+          <a:blip r:embed="rId1">
+            <a:lum/>
+          </a:blip>
+          <a:srcRect/>
+          <a:stretch>
+            <a:fillRect/>
+          </a:stretch>
+        </a:blipFill>
+        <a:effectLst/>
+      </p:bgPr>
+    </p:bg>
+    <p:spTree>
+      <p:nvGrpSpPr>
+        <p:cNvPr id="1" name=""/>
+        <p:cNvGrpSpPr/>
+        <p:nvPr/>
+      </p:nvGrpSpPr>
+      <p:grpSpPr>
+        <a:xfrm>
+          <a:off x="0" y="0"/>
+          <a:ext cx="0" cy="0"/>
+          <a:chOff x="0" y="0"/>
+          <a:chExt cx="0" cy="0"/>
+        </a:xfrm>
+      </p:grpSpPr>
+    </p:spTree>
+  </p:cSld>
+  <p:clrMapOvr>
+    <a:masterClrMapping/>
+  </p:clrMapOvr>
+</p:sld>
+</file>
+
+<file path=ppt/slides/slide39.xml><?xml version="1.0" encoding="utf-8"?>
+<p:sld xmlns:a="http://schemas.openxmlformats.org/drawingml/2006/main" xmlns:r="http://schemas.openxmlformats.org/officeDocument/2006/relationships" xmlns:p="http://schemas.openxmlformats.org/presentationml/2006/main">
+  <p:cSld name="Slide 39">
     <p:bg>
       <p:bgPr>
         <a:blipFill dpi="0" rotWithShape="1">

</xml_diff>